<commit_message>
feat(security): harden Sprint 3 controls
- Tighten API, ML, and mobile security controls
- Expand CI with SAST, dependency audits, and secret scanning
- Update security docs and Sprint 3 deliverables
</commit_message>
<xml_diff>
--- a/docs/deliverables/Apresentacao_FaroAI.pptx
+++ b/docs/deliverables/Apresentacao_FaroAI.pptx
@@ -2946,7 +2946,7 @@
                 <a:ea typeface="Calibri" pitchFamily="34" charset="-122"/>
                 <a:cs typeface="Calibri" pitchFamily="34" charset="-120"/>
               </a:rPr>
-              <a:t>5 eixos de segurança — 100 pts cobertos</a:t>
+              <a:t>Segurança no Sprint 3 · 10 pontos</a:t>
             </a:r>
             <a:endParaRPr lang="en-US" sz="3200" dirty="0"/>
           </a:p>
@@ -3065,7 +3065,7 @@
         </p:nvSpPr>
         <p:spPr>
           <a:xfrm>
-            <a:off x="457200" y="1783080"/>
+            <a:off x="457200" y="1965960"/>
             <a:ext cx="11247120" cy="731520"/>
           </a:xfrm>
           <a:prstGeom prst="roundRect">
@@ -3092,7 +3092,7 @@
         </p:nvSpPr>
         <p:spPr>
           <a:xfrm>
-            <a:off x="640080" y="1920240"/>
+            <a:off x="640080" y="2103120"/>
             <a:ext cx="914400" cy="457200"/>
           </a:xfrm>
           <a:prstGeom prst="roundRect">
@@ -3119,7 +3119,7 @@
         </p:nvSpPr>
         <p:spPr>
           <a:xfrm>
-            <a:off x="640080" y="1920240"/>
+            <a:off x="640080" y="2103120"/>
             <a:ext cx="914400" cy="457200"/>
           </a:xfrm>
           <a:prstGeom prst="rect">
@@ -3144,7 +3144,7 @@
                 <a:ea typeface="Calibri" pitchFamily="34" charset="-122"/>
                 <a:cs typeface="Calibri" pitchFamily="34" charset="-120"/>
               </a:rPr>
-              <a:t>20 pts</a:t>
+              <a:t>3,0 pts</a:t>
             </a:r>
             <a:endParaRPr lang="en-US" sz="1200" dirty="0"/>
           </a:p>
@@ -3158,7 +3158,7 @@
         </p:nvSpPr>
         <p:spPr>
           <a:xfrm>
-            <a:off x="1737360" y="1874520"/>
+            <a:off x="1737360" y="2057400"/>
             <a:ext cx="4114800" cy="320040"/>
           </a:xfrm>
           <a:prstGeom prst="rect">
@@ -3183,7 +3183,7 @@
                 <a:ea typeface="Calibri" pitchFamily="34" charset="-122"/>
                 <a:cs typeface="Calibri" pitchFamily="34" charset="-120"/>
               </a:rPr>
-              <a:t>Validação &amp; Sanitização</a:t>
+              <a:t>DevSecOps e pipeline</a:t>
             </a:r>
             <a:endParaRPr lang="en-US" sz="1300" dirty="0"/>
           </a:p>
@@ -3197,7 +3197,7 @@
         </p:nvSpPr>
         <p:spPr>
           <a:xfrm>
-            <a:off x="1737360" y="2167128"/>
+            <a:off x="1737360" y="2350008"/>
             <a:ext cx="9784080" cy="320040"/>
           </a:xfrm>
           <a:prstGeom prst="rect">
@@ -3222,7 +3222,7 @@
                 <a:ea typeface="Calibri" pitchFamily="34" charset="-122"/>
                 <a:cs typeface="Calibri" pitchFamily="34" charset="-120"/>
               </a:rPr>
-              <a:t>Zod em todas rotas · sem SQL raw · rate-limit 120 req/min · Helmet · multipart 30MB</a:t>
+              <a:t>Typecheck · Semgrep · pnpm audit · pip-audit · Gitleaks · Dependabot</a:t>
             </a:r>
             <a:endParaRPr lang="en-US" sz="1000" dirty="0"/>
           </a:p>
@@ -3236,7 +3236,7 @@
         </p:nvSpPr>
         <p:spPr>
           <a:xfrm>
-            <a:off x="457200" y="2651760"/>
+            <a:off x="457200" y="2926080"/>
             <a:ext cx="11247120" cy="731520"/>
           </a:xfrm>
           <a:prstGeom prst="roundRect">
@@ -3263,7 +3263,7 @@
         </p:nvSpPr>
         <p:spPr>
           <a:xfrm>
-            <a:off x="640080" y="2788920"/>
+            <a:off x="640080" y="3063240"/>
             <a:ext cx="914400" cy="457200"/>
           </a:xfrm>
           <a:prstGeom prst="roundRect">
@@ -3290,7 +3290,7 @@
         </p:nvSpPr>
         <p:spPr>
           <a:xfrm>
-            <a:off x="640080" y="2788920"/>
+            <a:off x="640080" y="3063240"/>
             <a:ext cx="914400" cy="457200"/>
           </a:xfrm>
           <a:prstGeom prst="rect">
@@ -3315,7 +3315,7 @@
                 <a:ea typeface="Calibri" pitchFamily="34" charset="-122"/>
                 <a:cs typeface="Calibri" pitchFamily="34" charset="-120"/>
               </a:rPr>
-              <a:t>20 pts</a:t>
+              <a:t>2,5 pts</a:t>
             </a:r>
             <a:endParaRPr lang="en-US" sz="1200" dirty="0"/>
           </a:p>
@@ -3329,7 +3329,7 @@
         </p:nvSpPr>
         <p:spPr>
           <a:xfrm>
-            <a:off x="1737360" y="2743200"/>
+            <a:off x="1737360" y="3017520"/>
             <a:ext cx="4114800" cy="320040"/>
           </a:xfrm>
           <a:prstGeom prst="rect">
@@ -3354,7 +3354,7 @@
                 <a:ea typeface="Calibri" pitchFamily="34" charset="-122"/>
                 <a:cs typeface="Calibri" pitchFamily="34" charset="-120"/>
               </a:rPr>
-              <a:t>Autenticação &amp; RBAC</a:t>
+              <a:t>Código e infraestrutura</a:t>
             </a:r>
             <a:endParaRPr lang="en-US" sz="1300" dirty="0"/>
           </a:p>
@@ -3368,7 +3368,7 @@
         </p:nvSpPr>
         <p:spPr>
           <a:xfrm>
-            <a:off x="1737360" y="3035808"/>
+            <a:off x="1737360" y="3310128"/>
             <a:ext cx="9784080" cy="320040"/>
           </a:xfrm>
           <a:prstGeom prst="rect">
@@ -3393,7 +3393,7 @@
                 <a:ea typeface="Calibri" pitchFamily="34" charset="-122"/>
                 <a:cs typeface="Calibri" pitchFamily="34" charset="-120"/>
               </a:rPr>
-              <a:t>JWT Supabase com expiração · 3 papéis (analista/gestor/admin) · RLS Postgres por dealership</a:t>
+              <a:t>RBAC · RLS · HMAC com nonce · SecureStore · e-books em domínios oficiais</a:t>
             </a:r>
             <a:endParaRPr lang="en-US" sz="1000" dirty="0"/>
           </a:p>
@@ -3407,7 +3407,7 @@
         </p:nvSpPr>
         <p:spPr>
           <a:xfrm>
-            <a:off x="457200" y="3520440"/>
+            <a:off x="457200" y="3886200"/>
             <a:ext cx="11247120" cy="731520"/>
           </a:xfrm>
           <a:prstGeom prst="roundRect">
@@ -3434,7 +3434,7 @@
         </p:nvSpPr>
         <p:spPr>
           <a:xfrm>
-            <a:off x="640080" y="3657600"/>
+            <a:off x="640080" y="4023360"/>
             <a:ext cx="914400" cy="457200"/>
           </a:xfrm>
           <a:prstGeom prst="roundRect">
@@ -3461,7 +3461,7 @@
         </p:nvSpPr>
         <p:spPr>
           <a:xfrm>
-            <a:off x="640080" y="3657600"/>
+            <a:off x="640080" y="4023360"/>
             <a:ext cx="914400" cy="457200"/>
           </a:xfrm>
           <a:prstGeom prst="rect">
@@ -3486,7 +3486,7 @@
                 <a:ea typeface="Calibri" pitchFamily="34" charset="-122"/>
                 <a:cs typeface="Calibri" pitchFamily="34" charset="-120"/>
               </a:rPr>
-              <a:t>20 pts</a:t>
+              <a:t>2,0 pts</a:t>
             </a:r>
             <a:endParaRPr lang="en-US" sz="1200" dirty="0"/>
           </a:p>
@@ -3500,7 +3500,7 @@
         </p:nvSpPr>
         <p:spPr>
           <a:xfrm>
-            <a:off x="1737360" y="3611880"/>
+            <a:off x="1737360" y="3977640"/>
             <a:ext cx="4114800" cy="320040"/>
           </a:xfrm>
           <a:prstGeom prst="rect">
@@ -3525,7 +3525,7 @@
                 <a:ea typeface="Calibri" pitchFamily="34" charset="-122"/>
                 <a:cs typeface="Calibri" pitchFamily="34" charset="-120"/>
               </a:rPr>
-              <a:t>Proteção de APIs</a:t>
+              <a:t>Monitoramento e resposta</a:t>
             </a:r>
             <a:endParaRPr lang="en-US" sz="1300" dirty="0"/>
           </a:p>
@@ -3539,7 +3539,7 @@
         </p:nvSpPr>
         <p:spPr>
           <a:xfrm>
-            <a:off x="1737360" y="3904488"/>
+            <a:off x="1737360" y="4270248"/>
             <a:ext cx="9784080" cy="320040"/>
           </a:xfrm>
           <a:prstGeom prst="rect">
@@ -3564,7 +3564,7 @@
                 <a:ea typeface="Calibri" pitchFamily="34" charset="-122"/>
                 <a:cs typeface="Calibri" pitchFamily="34" charset="-120"/>
               </a:rPr>
-              <a:t>HTTPS/TLS 1.3 · CORS allowlist · HMAC X-Payload-Signature no ML · throttling</a:t>
+              <a:t>Pino · audit_log · alertas centralizados pendentes no deploy</a:t>
             </a:r>
             <a:endParaRPr lang="en-US" sz="1000" dirty="0"/>
           </a:p>
@@ -3578,7 +3578,7 @@
         </p:nvSpPr>
         <p:spPr>
           <a:xfrm>
-            <a:off x="457200" y="4389120"/>
+            <a:off x="457200" y="4846320"/>
             <a:ext cx="11247120" cy="731520"/>
           </a:xfrm>
           <a:prstGeom prst="roundRect">
@@ -3605,7 +3605,7 @@
         </p:nvSpPr>
         <p:spPr>
           <a:xfrm>
-            <a:off x="640080" y="4526280"/>
+            <a:off x="640080" y="4983480"/>
             <a:ext cx="914400" cy="457200"/>
           </a:xfrm>
           <a:prstGeom prst="roundRect">
@@ -3632,7 +3632,7 @@
         </p:nvSpPr>
         <p:spPr>
           <a:xfrm>
-            <a:off x="640080" y="4526280"/>
+            <a:off x="640080" y="4983480"/>
             <a:ext cx="914400" cy="457200"/>
           </a:xfrm>
           <a:prstGeom prst="rect">
@@ -3657,7 +3657,7 @@
                 <a:ea typeface="Calibri" pitchFamily="34" charset="-122"/>
                 <a:cs typeface="Calibri" pitchFamily="34" charset="-120"/>
               </a:rPr>
-              <a:t>25 pts</a:t>
+              <a:t>2,5 pts</a:t>
             </a:r>
             <a:endParaRPr lang="en-US" sz="1200" dirty="0"/>
           </a:p>
@@ -3671,7 +3671,7 @@
         </p:nvSpPr>
         <p:spPr>
           <a:xfrm>
-            <a:off x="1737360" y="4480560"/>
+            <a:off x="1737360" y="4937760"/>
             <a:ext cx="4114800" cy="320040"/>
           </a:xfrm>
           <a:prstGeom prst="rect">
@@ -3696,7 +3696,7 @@
                 <a:ea typeface="Calibri" pitchFamily="34" charset="-122"/>
                 <a:cs typeface="Calibri" pitchFamily="34" charset="-120"/>
               </a:rPr>
-              <a:t>Dados &amp; Privacidade</a:t>
+              <a:t>Compliance e segurança contínua</a:t>
             </a:r>
             <a:endParaRPr lang="en-US" sz="1300" dirty="0"/>
           </a:p>
@@ -3710,7 +3710,7 @@
         </p:nvSpPr>
         <p:spPr>
           <a:xfrm>
-            <a:off x="1737360" y="4773168"/>
+            <a:off x="1737360" y="5230368"/>
             <a:ext cx="9784080" cy="320040"/>
           </a:xfrm>
           <a:prstGeom prst="rect">
@@ -3735,7 +3735,7 @@
                 <a:ea typeface="Calibri" pitchFamily="34" charset="-122"/>
                 <a:cs typeface="Calibri" pitchFamily="34" charset="-120"/>
               </a:rPr>
-              <a:t>AES-256 at rest · VIN_Hash (pseudonimização) · sem PII em prompts de IA · LGPD-ready</a:t>
+              <a:t>Minimização · CPF com HMAC · dados financeiros em ML/IA · retenção pendente</a:t>
             </a:r>
             <a:endParaRPr lang="en-US" sz="1000" dirty="0"/>
           </a:p>
@@ -3743,178 +3743,7 @@
       </p:sp>
       <p:sp>
         <p:nvSpPr>
-          <p:cNvPr id="27" name="Shape 25"/>
-          <p:cNvSpPr/>
-          <p:nvPr/>
-        </p:nvSpPr>
-        <p:spPr>
-          <a:xfrm>
-            <a:off x="457200" y="5257800"/>
-            <a:ext cx="11247120" cy="731520"/>
-          </a:xfrm>
-          <a:prstGeom prst="roundRect">
-            <a:avLst>
-              <a:gd name="adj" fmla="val 10000"/>
-            </a:avLst>
-          </a:prstGeom>
-          <a:solidFill>
-            <a:srgbClr val="152844"/>
-          </a:solidFill>
-          <a:ln w="12700">
-            <a:solidFill>
-              <a:srgbClr val="20354A"/>
-            </a:solidFill>
-            <a:prstDash val="solid"/>
-          </a:ln>
-        </p:spPr>
-      </p:sp>
-      <p:sp>
-        <p:nvSpPr>
-          <p:cNvPr id="28" name="Shape 26"/>
-          <p:cNvSpPr/>
-          <p:nvPr/>
-        </p:nvSpPr>
-        <p:spPr>
-          <a:xfrm>
-            <a:off x="640080" y="5394960"/>
-            <a:ext cx="914400" cy="457200"/>
-          </a:xfrm>
-          <a:prstGeom prst="roundRect">
-            <a:avLst>
-              <a:gd name="adj" fmla="val 50000"/>
-            </a:avLst>
-          </a:prstGeom>
-          <a:solidFill>
-            <a:srgbClr val="E63946"/>
-          </a:solidFill>
-          <a:ln w="12700">
-            <a:solidFill>
-              <a:srgbClr val="E63946"/>
-            </a:solidFill>
-            <a:prstDash val="solid"/>
-          </a:ln>
-        </p:spPr>
-      </p:sp>
-      <p:sp>
-        <p:nvSpPr>
-          <p:cNvPr id="29" name="Text 27"/>
-          <p:cNvSpPr/>
-          <p:nvPr/>
-        </p:nvSpPr>
-        <p:spPr>
-          <a:xfrm>
-            <a:off x="640080" y="5394960"/>
-            <a:ext cx="914400" cy="457200"/>
-          </a:xfrm>
-          <a:prstGeom prst="rect">
-            <a:avLst/>
-          </a:prstGeom>
-          <a:noFill/>
-          <a:ln/>
-        </p:spPr>
-        <p:txBody>
-          <a:bodyPr wrap="square" rtlCol="0" anchor="ctr"/>
-          <a:lstStyle/>
-          <a:p>
-            <a:pPr algn="ctr" indent="0" marL="0">
-              <a:buNone/>
-            </a:pPr>
-            <a:r>
-              <a:rPr lang="en-US" sz="1200" b="1" dirty="0">
-                <a:solidFill>
-                  <a:srgbClr val="FFFFFF"/>
-                </a:solidFill>
-                <a:latin typeface="Calibri" pitchFamily="34" charset="0"/>
-                <a:ea typeface="Calibri" pitchFamily="34" charset="-122"/>
-                <a:cs typeface="Calibri" pitchFamily="34" charset="-120"/>
-              </a:rPr>
-              <a:t>15 pts</a:t>
-            </a:r>
-            <a:endParaRPr lang="en-US" sz="1200" dirty="0"/>
-          </a:p>
-        </p:txBody>
-      </p:sp>
-      <p:sp>
-        <p:nvSpPr>
-          <p:cNvPr id="30" name="Text 28"/>
-          <p:cNvSpPr/>
-          <p:nvPr/>
-        </p:nvSpPr>
-        <p:spPr>
-          <a:xfrm>
-            <a:off x="1737360" y="5349240"/>
-            <a:ext cx="4114800" cy="320040"/>
-          </a:xfrm>
-          <a:prstGeom prst="rect">
-            <a:avLst/>
-          </a:prstGeom>
-          <a:noFill/>
-          <a:ln/>
-        </p:spPr>
-        <p:txBody>
-          <a:bodyPr wrap="square" rtlCol="0" anchor="ctr"/>
-          <a:lstStyle/>
-          <a:p>
-            <a:pPr indent="0" marL="0">
-              <a:buNone/>
-            </a:pPr>
-            <a:r>
-              <a:rPr lang="en-US" sz="1300" b="1" dirty="0">
-                <a:solidFill>
-                  <a:srgbClr val="FFFFFF"/>
-                </a:solidFill>
-                <a:latin typeface="Calibri" pitchFamily="34" charset="0"/>
-                <a:ea typeface="Calibri" pitchFamily="34" charset="-122"/>
-                <a:cs typeface="Calibri" pitchFamily="34" charset="-120"/>
-              </a:rPr>
-              <a:t>Monitoramento &amp; Logs</a:t>
-            </a:r>
-            <a:endParaRPr lang="en-US" sz="1300" dirty="0"/>
-          </a:p>
-        </p:txBody>
-      </p:sp>
-      <p:sp>
-        <p:nvSpPr>
-          <p:cNvPr id="31" name="Text 29"/>
-          <p:cNvSpPr/>
-          <p:nvPr/>
-        </p:nvSpPr>
-        <p:spPr>
-          <a:xfrm>
-            <a:off x="1737360" y="5641848"/>
-            <a:ext cx="9784080" cy="320040"/>
-          </a:xfrm>
-          <a:prstGeom prst="rect">
-            <a:avLst/>
-          </a:prstGeom>
-          <a:noFill/>
-          <a:ln/>
-        </p:spPr>
-        <p:txBody>
-          <a:bodyPr wrap="square" rtlCol="0" anchor="ctr"/>
-          <a:lstStyle/>
-          <a:p>
-            <a:pPr indent="0" marL="0">
-              <a:buNone/>
-            </a:pPr>
-            <a:r>
-              <a:rPr lang="en-US" sz="1000" dirty="0">
-                <a:solidFill>
-                  <a:srgbClr val="CADCFC"/>
-                </a:solidFill>
-                <a:latin typeface="Calibri" pitchFamily="34" charset="0"/>
-                <a:ea typeface="Calibri" pitchFamily="34" charset="-122"/>
-                <a:cs typeface="Calibri" pitchFamily="34" charset="-120"/>
-              </a:rPr>
-              <a:t>audit_log estruturado · sem stack trace ao cliente · email_logs LGPD · trilha completa</a:t>
-            </a:r>
-            <a:endParaRPr lang="en-US" sz="1000" dirty="0"/>
-          </a:p>
-        </p:txBody>
-      </p:sp>
-      <p:sp>
-        <p:nvSpPr>
-          <p:cNvPr id="32" name="Text 30"/>
+          <p:cNvPr id="27" name="Text 25"/>
           <p:cNvSpPr/>
           <p:nvPr/>
         </p:nvSpPr>
@@ -4016,7 +3845,7 @@
                 <a:ea typeface="Calibri" pitchFamily="34" charset="-122"/>
                 <a:cs typeface="Calibri" pitchFamily="34" charset="-120"/>
               </a:rPr>
-              <a:t>DISCIPLINA 2 · MOBILE &amp; IoT</a:t>
+              <a:t>DISCIPLINA 2 · MOBILE DEVELOPMENT</a:t>
             </a:r>
             <a:endParaRPr lang="en-US" sz="1000" dirty="0"/>
           </a:p>
@@ -4358,7 +4187,7 @@
                 <a:ea typeface="Calibri" pitchFamily="34" charset="-122"/>
                 <a:cs typeface="Calibri" pitchFamily="34" charset="-120"/>
               </a:rPr>
-              <a:t>AsyncStorage + Supabase JS</a:t>
+              <a:t>SecureStore nativo · storage do navegador na web</a:t>
             </a:r>
             <a:endParaRPr lang="en-US" sz="1200" dirty="0"/>
           </a:p>
@@ -6902,7 +6731,7 @@
                 <a:ea typeface="Calibri" pitchFamily="34" charset="-122"/>
                 <a:cs typeface="Calibri" pitchFamily="34" charset="-120"/>
               </a:rPr>
-              <a:t>LGPD-first</a:t>
+              <a:t>Controles de acesso</a:t>
             </a:r>
             <a:endParaRPr lang="en-US" sz="1000" dirty="0"/>
           </a:p>
@@ -6966,7 +6795,7 @@
                 <a:ea typeface="Calibri" pitchFamily="34" charset="-122"/>
                 <a:cs typeface="Calibri" pitchFamily="34" charset="-120"/>
               </a:rPr>
-              <a:t>✓ VIN_Hash+RLS</a:t>
+              <a:t>✓ RLS + minimização</a:t>
             </a:r>
             <a:endParaRPr lang="en-US" sz="1000" dirty="0"/>
           </a:p>
@@ -7222,7 +7051,7 @@
                 <a:ea typeface="Calibri" pitchFamily="34" charset="-122"/>
                 <a:cs typeface="Calibri" pitchFamily="34" charset="-120"/>
               </a:rPr>
-              <a:t>Pronto em produção</a:t>
+              <a:t>Arquitetura prod-ready</a:t>
             </a:r>
             <a:endParaRPr lang="en-US" sz="1000" dirty="0"/>
           </a:p>
@@ -7286,7 +7115,7 @@
                 <a:ea typeface="Calibri" pitchFamily="34" charset="-122"/>
                 <a:cs typeface="Calibri" pitchFamily="34" charset="-120"/>
               </a:rPr>
-              <a:t>✓ Hoje</a:t>
+              <a:t>MVP funcional</a:t>
             </a:r>
             <a:endParaRPr lang="en-US" sz="1000" dirty="0"/>
           </a:p>
@@ -7876,7 +7705,7 @@
                 <a:ea typeface="Calibri" pitchFamily="34" charset="-122"/>
                 <a:cs typeface="Calibri" pitchFamily="34" charset="-120"/>
               </a:rPr>
-              <a:t>Stack brasileira · IA explicável · ML hybrid + LLM crítico · MVP em produção · LGPD by design</a:t>
+              <a:t>Stack brasileira · IA explicável · controles no app · deploy e adequação LGPD pendentes</a:t>
             </a:r>
             <a:endParaRPr lang="en-US" sz="1100" dirty="0"/>
           </a:p>
@@ -8520,7 +8349,7 @@
                 <a:ea typeface="Calibri" pitchFamily="34" charset="-122"/>
                 <a:cs typeface="Calibri" pitchFamily="34" charset="-120"/>
               </a:rPr>
-              <a:t>API telematics · dashboards regionais · KPIs financeiros</a:t>
+              <a:t>DevSecOps · RBAC/RLS · HMAC anti-replay · SecureStore</a:t>
             </a:r>
             <a:endParaRPr lang="en-US" sz="1000" dirty="0"/>
           </a:p>
@@ -9074,7 +8903,7 @@
                   <a:srgbClr val="2A3A4A"/>
                 </a:solidFill>
               </a:rPr>
-              <a:t>Segurança: RLS · HMAC · audit log LGPD
+              <a:t>Segurança: RBAC · RLS · HMAC · audit log; TLS e alertas pendentes no deploy
 </a:t>
             </a:r>
             <a:pPr indent="0" marL="0">
@@ -12207,7 +12036,7 @@
                 <a:ea typeface="Calibri" pitchFamily="34" charset="-122"/>
                 <a:cs typeface="Calibri" pitchFamily="34" charset="-120"/>
               </a:rPr>
-              <a:t>E-mail real via Resend com template por perfil. Auditoria LGPD. Loop fechado de retenção.</a:t>
+              <a:t>E-mail via Resend com template por perfil. Ação e envio ficam registrados.</a:t>
             </a:r>
             <a:endParaRPr lang="en-US" sz="1200" dirty="0"/>
           </a:p>
@@ -14872,7 +14701,7 @@
                 <a:ea typeface="Calibri" pitchFamily="34" charset="-122"/>
                 <a:cs typeface="Calibri" pitchFamily="34" charset="-120"/>
               </a:rPr>
-              <a:t>Ação fica auditada</a:t>
+              <a:t>Ação fica registrada</a:t>
             </a:r>
             <a:endParaRPr lang="en-US" sz="1200" dirty="0"/>
           </a:p>
@@ -14911,7 +14740,7 @@
                 <a:ea typeface="Calibri" pitchFamily="34" charset="-122"/>
                 <a:cs typeface="Calibri" pitchFamily="34" charset="-120"/>
               </a:rPr>
-              <a:t>email_logs + acoes_retencao + LGPD</a:t>
+              <a:t>email_logs + acoes_retencao + audit_log</a:t>
             </a:r>
             <a:endParaRPr lang="en-US" sz="1000" dirty="0"/>
           </a:p>
@@ -15876,7 +15705,7 @@
                 <a:ea typeface="Calibri" pitchFamily="34" charset="-122"/>
                 <a:cs typeface="Calibri" pitchFamily="34" charset="-120"/>
               </a:rPr>
-              <a:t>Postgres (Supabase) · 18 migrations</a:t>
+              <a:t>Postgres (Supabase) · 19 migrations</a:t>
             </a:r>
             <a:endParaRPr lang="en-US" sz="1100" dirty="0"/>
           </a:p>
@@ -16035,7 +15864,7 @@
                 <a:ea typeface="Calibri" pitchFamily="34" charset="-122"/>
                 <a:cs typeface="Calibri" pitchFamily="34" charset="-120"/>
               </a:rPr>
-              <a:t>HMAC X-Payload-Signature</a:t>
+              <a:t>HMAC · timestamp · nonce</a:t>
             </a:r>
             <a:endParaRPr lang="en-US" sz="1100" dirty="0"/>
           </a:p>

</xml_diff>